<commit_message>
Site updated: 2019-10-10 13:44:55
</commit_message>
<xml_diff>
--- a/2019/09/19/algorithm/mrc.pptx
+++ b/2019/09/19/algorithm/mrc.pptx
@@ -31266,7 +31266,7 @@
         </p:nvSpPr>
         <p:spPr>
           <a:xfrm>
-            <a:off x="2036618" y="3429000"/>
+            <a:off x="1511707" y="3728258"/>
             <a:ext cx="153785" cy="153785"/>
           </a:xfrm>
           <a:prstGeom prst="rect">
@@ -31318,7 +31318,7 @@
         </p:nvSpPr>
         <p:spPr>
           <a:xfrm>
-            <a:off x="2314654" y="3321226"/>
+            <a:off x="1789743" y="3620484"/>
             <a:ext cx="927310" cy="369332"/>
           </a:xfrm>
           <a:prstGeom prst="rect">
@@ -31355,7 +31355,7 @@
         </p:nvSpPr>
         <p:spPr>
           <a:xfrm>
-            <a:off x="3640972" y="3427597"/>
+            <a:off x="3116061" y="3726855"/>
             <a:ext cx="153785" cy="153785"/>
           </a:xfrm>
           <a:prstGeom prst="rect">
@@ -31407,7 +31407,7 @@
         </p:nvSpPr>
         <p:spPr>
           <a:xfrm>
-            <a:off x="3919008" y="3319823"/>
+            <a:off x="3394097" y="3619081"/>
             <a:ext cx="927310" cy="369332"/>
           </a:xfrm>
           <a:prstGeom prst="rect">
@@ -31444,7 +31444,7 @@
         </p:nvSpPr>
         <p:spPr>
           <a:xfrm>
-            <a:off x="5245326" y="3427597"/>
+            <a:off x="4720415" y="3726855"/>
             <a:ext cx="153785" cy="153785"/>
           </a:xfrm>
           <a:prstGeom prst="rect">
@@ -31495,7 +31495,7 @@
         </p:nvSpPr>
         <p:spPr>
           <a:xfrm>
-            <a:off x="5440230" y="3319823"/>
+            <a:off x="4915319" y="3619081"/>
             <a:ext cx="1093574" cy="369332"/>
           </a:xfrm>
           <a:prstGeom prst="rect">
@@ -31513,6 +31513,92 @@
             <a:r>
               <a:rPr lang="en-US" altLang="zh-CN" dirty="0"/>
               <a:t>Replace</a:t>
+            </a:r>
+            <a:endParaRPr lang="zh-CN" altLang="en-US" dirty="0"/>
+          </a:p>
+        </p:txBody>
+      </p:sp>
+      <p:sp>
+        <p:nvSpPr>
+          <p:cNvPr id="19" name="矩形 18">
+            <a:extLst>
+              <a:ext uri="{FF2B5EF4-FFF2-40B4-BE49-F238E27FC236}">
+                <a16:creationId xmlns:a16="http://schemas.microsoft.com/office/drawing/2014/main" id="{10B76353-9CF2-4E1A-9D04-41CCD12A8AC1}"/>
+              </a:ext>
+            </a:extLst>
+          </p:cNvPr>
+          <p:cNvSpPr/>
+          <p:nvPr/>
+        </p:nvSpPr>
+        <p:spPr>
+          <a:xfrm>
+            <a:off x="6407901" y="3726855"/>
+            <a:ext cx="153785" cy="153785"/>
+          </a:xfrm>
+          <a:prstGeom prst="rect">
+            <a:avLst/>
+          </a:prstGeom>
+          <a:solidFill>
+            <a:schemeClr val="bg1"/>
+          </a:solidFill>
+        </p:spPr>
+        <p:style>
+          <a:lnRef idx="2">
+            <a:schemeClr val="accent1">
+              <a:shade val="50000"/>
+            </a:schemeClr>
+          </a:lnRef>
+          <a:fillRef idx="1">
+            <a:schemeClr val="accent1"/>
+          </a:fillRef>
+          <a:effectRef idx="0">
+            <a:schemeClr val="accent1"/>
+          </a:effectRef>
+          <a:fontRef idx="minor">
+            <a:schemeClr val="lt1"/>
+          </a:fontRef>
+        </p:style>
+        <p:txBody>
+          <a:bodyPr rtlCol="0" anchor="ctr"/>
+          <a:lstStyle/>
+          <a:p>
+            <a:pPr algn="ctr"/>
+            <a:endParaRPr lang="zh-CN" altLang="en-US"/>
+          </a:p>
+        </p:txBody>
+      </p:sp>
+      <p:sp>
+        <p:nvSpPr>
+          <p:cNvPr id="20" name="文本框 19">
+            <a:extLst>
+              <a:ext uri="{FF2B5EF4-FFF2-40B4-BE49-F238E27FC236}">
+                <a16:creationId xmlns:a16="http://schemas.microsoft.com/office/drawing/2014/main" id="{C7725155-C888-41A2-9F14-37A0061F282B}"/>
+              </a:ext>
+            </a:extLst>
+          </p:cNvPr>
+          <p:cNvSpPr txBox="1"/>
+          <p:nvPr/>
+        </p:nvSpPr>
+        <p:spPr>
+          <a:xfrm>
+            <a:off x="6602804" y="3619081"/>
+            <a:ext cx="1567397" cy="369332"/>
+          </a:xfrm>
+          <a:prstGeom prst="rect">
+            <a:avLst/>
+          </a:prstGeom>
+          <a:noFill/>
+        </p:spPr>
+        <p:txBody>
+          <a:bodyPr wrap="square" rtlCol="0">
+            <a:spAutoFit/>
+          </a:bodyPr>
+          <a:lstStyle/>
+          <a:p>
+            <a:pPr algn="ctr"/>
+            <a:r>
+              <a:rPr lang="en-US" altLang="zh-CN" dirty="0"/>
+              <a:t>No operation</a:t>
             </a:r>
             <a:endParaRPr lang="zh-CN" altLang="en-US" dirty="0"/>
           </a:p>

</xml_diff>